<commit_message>
出图从 R 改为 Python：新增 s04_figures.py，删除 s04_figures.R
- s04_figures.py：matplotlib 出同样的 11 张图（编号、尺寸、配色不变），宋体五号 + Times New Roman 五号按 C:\Windows\Fonts 路径加载，缺字体时退到替代字体并打印警告
- s00_env.py 改查 matplotlib，不再查 Rscript；run_all.bat 第四步改为 python s04_figures.py；requirements.txt 加 matplotlib
- figures/ 与 logs/s00、s04 用 Python 版重新生成
- PPT、讲稿、README、移交文档中的 R 相关表述同步改掉；移交文档第 7 节"出图 R"规范按用户要求改为 Python，第 10 节记录

Co-Authored-By: Claude Fable 5.1 <noreply@anthropic.com>
Claude-Session: https://claude.ai/code/session_01RmLkAgSqChk5G9i4XLoDT8
</commit_message>
<xml_diff>
--- a/RUL_censored_conformal_handover/01_slides/第二次课_从想法到能跑的东西.pptx
+++ b/RUL_censored_conformal_handover/01_slides/第二次课_从想法到能跑的东西.pptx
@@ -2900,7 +2900,7 @@
                 <a:ea typeface="Microsoft YaHei" pitchFamily="34" charset="-122"/>
                 <a:cs typeface="Microsoft YaHei" pitchFamily="34" charset="-120"/>
               </a:rPr>
-              <a:t>工具：Python 3.10 跑管线，R 4.5 出图；五个脚本，结果只在控制台打印并落盘到 results/</a:t>
+              <a:t>工具：Python 3.10，五个脚本；管线与出图都是 Python，结果只在控制台打印并落盘到 results/</a:t>
             </a:r>
             <a:endParaRPr lang="en-US" sz="1350" dirty="0"/>
           </a:p>
@@ -9669,7 +9669,7 @@
                 <a:ea typeface="Microsoft YaHei" pitchFamily="34" charset="-122"/>
                 <a:cs typeface="Microsoft YaHei" pitchFamily="34" charset="-120"/>
               </a:rPr>
-              <a:t>打印 Python 与 numpy / pandas / scikit-learn 版本，Rscript 是否在 PATH，宋体与 Times New Roman 字体文件是否存在，FD001 三个文件是否齐全。</a:t>
+              <a:t>打印 Python 与 numpy / pandas / scikit-learn / matplotlib 版本，宋体与 Times New Roman 字体文件是否存在，FD001 三个文件是否齐全。</a:t>
             </a:r>
             <a:endParaRPr lang="en-US" sz="1000" dirty="0"/>
           </a:p>
@@ -9753,7 +9753,7 @@
                 <a:ea typeface="Microsoft YaHei" pitchFamily="34" charset="-122"/>
                 <a:cs typeface="Microsoft YaHei" pitchFamily="34" charset="-120"/>
               </a:rPr>
-              <a:t>三个包有版本号；Rscript 找得到；两个字体都“有”</a:t>
+              <a:t>四个包有版本号；两个字体都“有”</a:t>
             </a:r>
             <a:endParaRPr lang="en-US" sz="1000" dirty="0"/>
           </a:p>
@@ -10760,7 +10760,7 @@
                 <a:ea typeface="Courier New" pitchFamily="34" charset="-122"/>
                 <a:cs typeface="Courier New" pitchFamily="34" charset="-120"/>
               </a:rPr>
-              <a:t>s04_figures.R</a:t>
+              <a:t>s04_figures.py</a:t>
             </a:r>
             <a:endParaRPr lang="en-US" sz="1200" dirty="0"/>
           </a:p>
@@ -10841,7 +10841,7 @@
                 <a:ea typeface="Microsoft YaHei" pitchFamily="34" charset="-122"/>
                 <a:cs typeface="Microsoft YaHei" pitchFamily="34" charset="-120"/>
               </a:rPr>
-              <a:t>读 results/ 的 CSV 出 11 张图到 figures/，宋体五号，Times New Roman 五号，PNG 与 PDF 各一份。</a:t>
+              <a:t>matplotlib 读 results/ 的 CSV 出 11 张图到 figures/，宋体五号，Times New Roman 五号，PNG 与 PDF 各一份。</a:t>
             </a:r>
             <a:endParaRPr lang="en-US" sz="1000" dirty="0"/>
           </a:p>
@@ -10925,7 +10925,7 @@
                 <a:ea typeface="Microsoft YaHei" pitchFamily="34" charset="-122"/>
                 <a:cs typeface="Microsoft YaHei" pitchFamily="34" charset="-120"/>
               </a:rPr>
-              <a:t>22 个文件；日志无“回退到系统字体”；F07 到 F09 目视无乱码</a:t>
+              <a:t>22 个文件；日志无“回退到替代字体”；F07 到 F09 目视无乱码</a:t>
             </a:r>
             <a:endParaRPr lang="en-US" sz="1000" dirty="0"/>
           </a:p>
@@ -11106,7 +11106,7 @@
                 <a:ea typeface="Microsoft YaHei" pitchFamily="34" charset="-122"/>
                 <a:cs typeface="Microsoft YaHei" pitchFamily="34" charset="-120"/>
               </a:rPr>
-              <a:t>s04_figures.R 生成，宋体五号，Times New Roman 五号，PNG 与 PDF 各一份；只出这 11 张，不自行加图</a:t>
+              <a:t>s04_figures.py 用 matplotlib 生成，宋体五号，Times New Roman 五号，PNG 与 PDF 各一份；只出这 11 张，不自行加图</a:t>
             </a:r>
             <a:endParaRPr lang="en-US" sz="1200" dirty="0"/>
           </a:p>
@@ -12849,7 +12849,7 @@
                 <a:ea typeface="Microsoft YaHei" pitchFamily="34" charset="-122"/>
                 <a:cs typeface="Microsoft YaHei" pitchFamily="34" charset="-120"/>
               </a:rPr>
-              <a:t>FD001，Python 3.11，numpy 2.4，pandas 3.0，scikit-learn 1.9；五个脚本全部退出码 0</a:t>
+              <a:t>FD001，Python 3.11，numpy 2.4，pandas 3.0，scikit-learn 1.9，matplotlib 3.11；五个脚本全部退出码 0</a:t>
             </a:r>
             <a:endParaRPr lang="en-US" sz="1200" dirty="0"/>
           </a:p>
@@ -15903,7 +15903,7 @@
                 <a:ea typeface="Microsoft YaHei" pitchFamily="34" charset="-122"/>
                 <a:cs typeface="Microsoft YaHei" pitchFamily="34" charset="-120"/>
               </a:rPr>
-              <a:t>图为 Linux 预览版（替代字体 Liberation Serif 与文泉驿）。论文用图在 Windows 上重跑 s04 即为宋体五号与 Times New Roman 五号。删失为人工构造。</a:t>
+              <a:t>图为 Linux 预览版（替代字体 Liberation Serif 与文泉驿）。论文用图在 Windows 上重跑 s04_figures.py 即为宋体五号与 Times New Roman 五号。删失为人工构造。</a:t>
             </a:r>
             <a:endParaRPr lang="en-US" sz="900" dirty="0"/>
           </a:p>
@@ -18209,7 +18209,7 @@
                 <a:ea typeface="Microsoft YaHei" pitchFamily="34" charset="-122"/>
                 <a:cs typeface="Microsoft YaHei" pitchFamily="34" charset="-120"/>
               </a:rPr>
-              <a:t>图为 Linux 预览版（替代字体 Liberation Serif 与文泉驿）。论文用图在 Windows 上重跑 s04 即为宋体五号与 Times New Roman 五号。删失为人工构造。</a:t>
+              <a:t>图为 Linux 预览版（替代字体 Liberation Serif 与文泉驿）。论文用图在 Windows 上重跑 s04_figures.py 即为宋体五号与 Times New Roman 五号。删失为人工构造。</a:t>
             </a:r>
             <a:endParaRPr lang="en-US" sz="900" dirty="0"/>
           </a:p>
@@ -18656,7 +18656,7 @@
                 <a:ea typeface="Microsoft YaHei" pitchFamily="34" charset="-122"/>
                 <a:cs typeface="Microsoft YaHei" pitchFamily="34" charset="-120"/>
               </a:rPr>
-              <a:t>图为 Linux 预览版（替代字体 Liberation Serif 与文泉驿）。论文用图在 Windows 上重跑 s04 即为宋体五号与 Times New Roman 五号。删失为人工构造。</a:t>
+              <a:t>图为 Linux 预览版（替代字体 Liberation Serif 与文泉驿）。论文用图在 Windows 上重跑 s04_figures.py 即为宋体五号与 Times New Roman 五号。删失为人工构造。</a:t>
             </a:r>
             <a:endParaRPr lang="en-US" sz="900" dirty="0"/>
           </a:p>
@@ -19797,7 +19797,7 @@
                 <a:ea typeface="Microsoft YaHei" pitchFamily="34" charset="-122"/>
                 <a:cs typeface="Microsoft YaHei" pitchFamily="34" charset="-120"/>
               </a:rPr>
-              <a:t>图为 Linux 预览版（替代字体 Liberation Serif 与文泉驿）。论文用图在 Windows 上重跑 s04 即为宋体五号与 Times New Roman 五号。删失为人工构造。</a:t>
+              <a:t>图为 Linux 预览版（替代字体 Liberation Serif 与文泉驿）。论文用图在 Windows 上重跑 s04_figures.py 即为宋体五号与 Times New Roman 五号。删失为人工构造。</a:t>
             </a:r>
             <a:endParaRPr lang="en-US" sz="900" dirty="0"/>
           </a:p>
@@ -21044,7 +21044,7 @@
                 <a:ea typeface="Microsoft YaHei" pitchFamily="34" charset="-122"/>
                 <a:cs typeface="Microsoft YaHei" pitchFamily="34" charset="-120"/>
               </a:rPr>
-              <a:t>五个脚本跑通（四个 Python 一个 R），控制台输出和图贴到群里，按移交文档第 9 节的顺序。跑不通的贴报错，不要自己改代码。</a:t>
+              <a:t>五个 Python 脚本跑通，控制台输出和图贴到群里，按移交文档第 9 节的顺序。跑不通的贴报错，不要自己改代码。</a:t>
             </a:r>
             <a:endParaRPr lang="en-US" sz="1200" dirty="0"/>
           </a:p>

</xml_diff>